<commit_message>
slide with some bARGE features
</commit_message>
<xml_diff>
--- a/ELSE26_TreasureHuntingInAzureWithKQL.pptx
+++ b/ELSE26_TreasureHuntingInAzureWithKQL.pptx
@@ -7732,13 +7732,18 @@
             <p:ph type="body" sz="quarter" idx="14"/>
           </p:nvPr>
         </p:nvSpPr>
-        <p:spPr/>
+        <p:spPr>
+          <a:xfrm>
+            <a:off x="1388410" y="3049575"/>
+            <a:ext cx="10890675" cy="2717800"/>
+          </a:xfrm>
+        </p:spPr>
         <p:txBody>
           <a:bodyPr/>
           <a:lstStyle/>
           <a:p>
             <a:r>
-              <a:rPr>
+              <a:rPr dirty="0">
                 <a:solidFill>
                   <a:srgbClr val="F7F9FF"/>
                 </a:solidFill>
@@ -7759,13 +7764,20 @@
             <p:ph type="body" sz="quarter" idx="15"/>
           </p:nvPr>
         </p:nvSpPr>
-        <p:spPr/>
+        <p:spPr>
+          <a:xfrm>
+            <a:off x="1388942" y="5143500"/>
+            <a:ext cx="9799638" cy="1358427"/>
+          </a:xfrm>
+        </p:spPr>
         <p:txBody>
-          <a:bodyPr/>
+          <a:bodyPr>
+            <a:normAutofit/>
+          </a:bodyPr>
           <a:lstStyle/>
           <a:p>
             <a:r>
-              <a:rPr sz="1700">
+              <a:rPr sz="2400" dirty="0">
                 <a:solidFill>
                   <a:srgbClr val="B8C4DC"/>
                 </a:solidFill>
@@ -7786,13 +7798,18 @@
             <p:ph type="body" sz="quarter" idx="16"/>
           </p:nvPr>
         </p:nvSpPr>
-        <p:spPr/>
+        <p:spPr>
+          <a:xfrm>
+            <a:off x="1366654" y="7153646"/>
+            <a:ext cx="4692090" cy="577850"/>
+          </a:xfrm>
+        </p:spPr>
         <p:txBody>
           <a:bodyPr/>
           <a:lstStyle/>
           <a:p>
             <a:r>
-              <a:rPr>
+              <a:rPr dirty="0">
                 <a:solidFill>
                   <a:srgbClr val="F7F9FF"/>
                 </a:solidFill>
@@ -7813,15 +7830,20 @@
             <p:ph type="body" sz="quarter" idx="18"/>
           </p:nvPr>
         </p:nvSpPr>
-        <p:spPr/>
+        <p:spPr>
+          <a:xfrm>
+            <a:off x="1366654" y="7677191"/>
+            <a:ext cx="8260268" cy="416762"/>
+          </a:xfrm>
+        </p:spPr>
         <p:txBody>
           <a:bodyPr/>
           <a:lstStyle/>
           <a:p>
             <a:r>
-              <a:rPr>
-                <a:solidFill>
-                  <a:srgbClr val="B8C4DC"/>
+              <a:rPr sz="1600" dirty="0">
+                <a:solidFill>
+                  <a:srgbClr val="FFC000"/>
                 </a:solidFill>
                 <a:latin typeface="Segoe UI"/>
               </a:rPr>
@@ -7830,35 +7852,6 @@
           </a:p>
         </p:txBody>
       </p:sp>
-      <p:pic>
-        <p:nvPicPr>
-          <p:cNvPr id="13" name="Picture Placeholder 12">
-            <a:extLst>
-              <a:ext uri="{FF2B5EF4-FFF2-40B4-BE49-F238E27FC236}">
-                <a16:creationId xmlns:a16="http://schemas.microsoft.com/office/drawing/2014/main" id="{361FA97F-EE2A-8548-B0FA-E232B9915430}"/>
-              </a:ext>
-            </a:extLst>
-          </p:cNvPr>
-          <p:cNvPicPr>
-            <a:picLocks noGrp="1" noChangeAspect="1"/>
-          </p:cNvPicPr>
-          <p:nvPr>
-            <p:ph type="pic" sz="quarter" idx="22"/>
-          </p:nvPr>
-        </p:nvPicPr>
-        <p:blipFill>
-          <a:blip r:embed="rId2"/>
-          <a:srcRect l="20" r="20"/>
-          <a:stretch>
-            <a:fillRect/>
-          </a:stretch>
-        </p:blipFill>
-        <p:spPr>
-          <a:prstGeom prst="rect">
-            <a:avLst/>
-          </a:prstGeom>
-        </p:spPr>
-      </p:pic>
       <p:sp>
         <p:nvSpPr>
           <p:cNvPr id="2" name="Rounded Rectangle 1">
@@ -8354,6 +8347,36 @@
           </a:p>
         </p:txBody>
       </p:sp>
+      <p:pic>
+        <p:nvPicPr>
+          <p:cNvPr id="14" name="Picture Placeholder 5" descr="speakerpng">
+            <a:extLst>
+              <a:ext uri="{FF2B5EF4-FFF2-40B4-BE49-F238E27FC236}">
+                <a16:creationId xmlns:a16="http://schemas.microsoft.com/office/drawing/2014/main" id="{5C1B59D3-1825-A6C4-D248-0815E5F84BC4}"/>
+              </a:ext>
+            </a:extLst>
+          </p:cNvPr>
+          <p:cNvPicPr>
+            <a:picLocks noGrp="1" noChangeAspect="1"/>
+          </p:cNvPicPr>
+          <p:nvPr>
+            <p:ph type="pic" sz="quarter" idx="22"/>
+          </p:nvPr>
+        </p:nvPicPr>
+        <p:blipFill>
+          <a:blip r:embed="rId2"/>
+          <a:srcRect t="748" b="748"/>
+          <a:stretch>
+            <a:fillRect/>
+          </a:stretch>
+        </p:blipFill>
+        <p:spPr>
+          <a:xfrm>
+            <a:off x="13849356" y="1074553"/>
+            <a:ext cx="4154328" cy="4092197"/>
+          </a:xfrm>
+        </p:spPr>
+      </p:pic>
     </p:spTree>
   </p:cSld>
   <p:clrMapOvr>
@@ -8395,13 +8418,13 @@
           <a:lstStyle/>
           <a:p>
             <a:r>
-              <a:rPr>
+              <a:rPr dirty="0">
                 <a:solidFill>
                   <a:srgbClr val="F7F9FF"/>
                 </a:solidFill>
                 <a:latin typeface="Segoe UI Semibold"/>
               </a:rPr>
-              <a:t>boosted Azure Resource Graph Explorer</a:t>
+              <a:t>Azure Resource Graph Explorer</a:t>
             </a:r>
           </a:p>
         </p:txBody>
@@ -8620,33 +8643,6 @@
           <a:chExt cx="0" cy="0"/>
         </a:xfrm>
       </p:grpSpPr>
-      <p:sp>
-        <p:nvSpPr>
-          <p:cNvPr id="9000" name="Title 1"/>
-          <p:cNvSpPr>
-            <a:spLocks noGrp="1"/>
-          </p:cNvSpPr>
-          <p:nvPr>
-            <p:ph type="title"/>
-          </p:nvPr>
-        </p:nvSpPr>
-        <p:spPr/>
-        <p:txBody>
-          <a:bodyPr/>
-          <a:lstStyle/>
-          <a:p>
-            <a:r>
-              <a:rPr>
-                <a:solidFill>
-                  <a:srgbClr val="F7F9FF"/>
-                </a:solidFill>
-                <a:latin typeface="Segoe UI Semibold"/>
-              </a:rPr>
-              <a:t>boosted Azure Resource Graph Explorer</a:t>
-            </a:r>
-          </a:p>
-        </p:txBody>
-      </p:sp>
       <p:pic>
         <p:nvPicPr>
           <p:cNvPr id="6" name="Picture 2">
@@ -8714,6 +8710,430 @@
           </a:sp3d>
         </p:spPr>
       </p:pic>
+      <p:sp>
+        <p:nvSpPr>
+          <p:cNvPr id="3" name="TextBox 2">
+            <a:extLst>
+              <a:ext uri="{FF2B5EF4-FFF2-40B4-BE49-F238E27FC236}">
+                <a16:creationId xmlns:a16="http://schemas.microsoft.com/office/drawing/2014/main" id="{22EB5539-B9D1-1AEA-372B-ADBA3AA148F5}"/>
+              </a:ext>
+            </a:extLst>
+          </p:cNvPr>
+          <p:cNvSpPr txBox="1"/>
+          <p:nvPr/>
+        </p:nvSpPr>
+        <p:spPr>
+          <a:xfrm>
+            <a:off x="1238250" y="2950146"/>
+            <a:ext cx="4724400" cy="523220"/>
+          </a:xfrm>
+          <a:prstGeom prst="rect">
+            <a:avLst/>
+          </a:prstGeom>
+          <a:noFill/>
+        </p:spPr>
+        <p:txBody>
+          <a:bodyPr wrap="square" rtlCol="0">
+            <a:spAutoFit/>
+          </a:bodyPr>
+          <a:lstStyle/>
+          <a:p>
+            <a:r>
+              <a:rPr lang="en-US" sz="2800" dirty="0">
+                <a:solidFill>
+                  <a:srgbClr val="FFC000"/>
+                </a:solidFill>
+                <a:latin typeface="Segoe UI" panose="020B0502040204020203" pitchFamily="34" charset="0"/>
+                <a:cs typeface="Segoe UI" panose="020B0502040204020203" pitchFamily="34" charset="0"/>
+              </a:rPr>
+              <a:t>IntelliSense for ARG KQL</a:t>
+            </a:r>
+          </a:p>
+        </p:txBody>
+      </p:sp>
+      <p:sp>
+        <p:nvSpPr>
+          <p:cNvPr id="4" name="TextBox 3">
+            <a:extLst>
+              <a:ext uri="{FF2B5EF4-FFF2-40B4-BE49-F238E27FC236}">
+                <a16:creationId xmlns:a16="http://schemas.microsoft.com/office/drawing/2014/main" id="{A01FCA16-310F-483C-7371-C1E88E0FD1CC}"/>
+              </a:ext>
+            </a:extLst>
+          </p:cNvPr>
+          <p:cNvSpPr txBox="1"/>
+          <p:nvPr/>
+        </p:nvSpPr>
+        <p:spPr>
+          <a:xfrm>
+            <a:off x="13257268" y="3138315"/>
+            <a:ext cx="4724400" cy="523220"/>
+          </a:xfrm>
+          <a:prstGeom prst="rect">
+            <a:avLst/>
+          </a:prstGeom>
+          <a:noFill/>
+        </p:spPr>
+        <p:txBody>
+          <a:bodyPr wrap="square" rtlCol="0">
+            <a:spAutoFit/>
+          </a:bodyPr>
+          <a:lstStyle/>
+          <a:p>
+            <a:r>
+              <a:rPr lang="en-US" sz="2800" dirty="0">
+                <a:solidFill>
+                  <a:srgbClr val="FFC000"/>
+                </a:solidFill>
+                <a:latin typeface="Segoe UI" panose="020B0502040204020203" pitchFamily="34" charset="0"/>
+                <a:cs typeface="Segoe UI" panose="020B0502040204020203" pitchFamily="34" charset="0"/>
+              </a:rPr>
+              <a:t>Syntax highlighting</a:t>
+            </a:r>
+          </a:p>
+        </p:txBody>
+      </p:sp>
+      <p:sp>
+        <p:nvSpPr>
+          <p:cNvPr id="5" name="TextBox 4">
+            <a:extLst>
+              <a:ext uri="{FF2B5EF4-FFF2-40B4-BE49-F238E27FC236}">
+                <a16:creationId xmlns:a16="http://schemas.microsoft.com/office/drawing/2014/main" id="{B4741B98-CAF5-862A-8BD1-08E46AC54BD9}"/>
+              </a:ext>
+            </a:extLst>
+          </p:cNvPr>
+          <p:cNvSpPr txBox="1"/>
+          <p:nvPr/>
+        </p:nvSpPr>
+        <p:spPr>
+          <a:xfrm>
+            <a:off x="2260068" y="4595254"/>
+            <a:ext cx="4724400" cy="523220"/>
+          </a:xfrm>
+          <a:prstGeom prst="rect">
+            <a:avLst/>
+          </a:prstGeom>
+          <a:noFill/>
+        </p:spPr>
+        <p:txBody>
+          <a:bodyPr wrap="square" rtlCol="0">
+            <a:spAutoFit/>
+          </a:bodyPr>
+          <a:lstStyle/>
+          <a:p>
+            <a:r>
+              <a:rPr lang="en-US" sz="2800" dirty="0">
+                <a:solidFill>
+                  <a:srgbClr val="FFC000"/>
+                </a:solidFill>
+                <a:latin typeface="Segoe UI" panose="020B0502040204020203" pitchFamily="34" charset="0"/>
+                <a:cs typeface="Segoe UI" panose="020B0502040204020203" pitchFamily="34" charset="0"/>
+              </a:rPr>
+              <a:t>Visualized result tables</a:t>
+            </a:r>
+          </a:p>
+        </p:txBody>
+      </p:sp>
+      <p:sp>
+        <p:nvSpPr>
+          <p:cNvPr id="7" name="TextBox 6">
+            <a:extLst>
+              <a:ext uri="{FF2B5EF4-FFF2-40B4-BE49-F238E27FC236}">
+                <a16:creationId xmlns:a16="http://schemas.microsoft.com/office/drawing/2014/main" id="{9615EAED-3A8D-7A5D-CED7-C71220D4A2AC}"/>
+              </a:ext>
+            </a:extLst>
+          </p:cNvPr>
+          <p:cNvSpPr txBox="1"/>
+          <p:nvPr/>
+        </p:nvSpPr>
+        <p:spPr>
+          <a:xfrm>
+            <a:off x="10313940" y="7946134"/>
+            <a:ext cx="4724400" cy="523220"/>
+          </a:xfrm>
+          <a:prstGeom prst="rect">
+            <a:avLst/>
+          </a:prstGeom>
+          <a:noFill/>
+        </p:spPr>
+        <p:txBody>
+          <a:bodyPr wrap="square" rtlCol="0">
+            <a:spAutoFit/>
+          </a:bodyPr>
+          <a:lstStyle/>
+          <a:p>
+            <a:r>
+              <a:rPr lang="en-US" sz="2800" dirty="0">
+                <a:solidFill>
+                  <a:srgbClr val="FFC000"/>
+                </a:solidFill>
+                <a:latin typeface="Segoe UI" panose="020B0502040204020203" pitchFamily="34" charset="0"/>
+                <a:cs typeface="Segoe UI" panose="020B0502040204020203" pitchFamily="34" charset="0"/>
+              </a:rPr>
+              <a:t>AI tooling in VS Code</a:t>
+            </a:r>
+          </a:p>
+        </p:txBody>
+      </p:sp>
+      <p:sp>
+        <p:nvSpPr>
+          <p:cNvPr id="8" name="TextBox 7">
+            <a:extLst>
+              <a:ext uri="{FF2B5EF4-FFF2-40B4-BE49-F238E27FC236}">
+                <a16:creationId xmlns:a16="http://schemas.microsoft.com/office/drawing/2014/main" id="{8AD6BF8D-7489-A47D-1B97-0CE8116F3F3A}"/>
+              </a:ext>
+            </a:extLst>
+          </p:cNvPr>
+          <p:cNvSpPr txBox="1"/>
+          <p:nvPr/>
+        </p:nvSpPr>
+        <p:spPr>
+          <a:xfrm>
+            <a:off x="4057650" y="8090842"/>
+            <a:ext cx="4724400" cy="523220"/>
+          </a:xfrm>
+          <a:prstGeom prst="rect">
+            <a:avLst/>
+          </a:prstGeom>
+          <a:noFill/>
+        </p:spPr>
+        <p:txBody>
+          <a:bodyPr wrap="square" rtlCol="0">
+            <a:spAutoFit/>
+          </a:bodyPr>
+          <a:lstStyle/>
+          <a:p>
+            <a:r>
+              <a:rPr lang="en-US" sz="2800" dirty="0">
+                <a:solidFill>
+                  <a:srgbClr val="FFC000"/>
+                </a:solidFill>
+                <a:latin typeface="Segoe UI" panose="020B0502040204020203" pitchFamily="34" charset="0"/>
+                <a:cs typeface="Segoe UI" panose="020B0502040204020203" pitchFamily="34" charset="0"/>
+              </a:rPr>
+              <a:t>Excel-like data filtering</a:t>
+            </a:r>
+          </a:p>
+        </p:txBody>
+      </p:sp>
+      <p:sp>
+        <p:nvSpPr>
+          <p:cNvPr id="9" name="TextBox 8">
+            <a:extLst>
+              <a:ext uri="{FF2B5EF4-FFF2-40B4-BE49-F238E27FC236}">
+                <a16:creationId xmlns:a16="http://schemas.microsoft.com/office/drawing/2014/main" id="{BEDB276D-CEDC-C859-6F33-5D52133BC533}"/>
+              </a:ext>
+            </a:extLst>
+          </p:cNvPr>
+          <p:cNvSpPr txBox="1"/>
+          <p:nvPr/>
+        </p:nvSpPr>
+        <p:spPr>
+          <a:xfrm>
+            <a:off x="12979408" y="6324414"/>
+            <a:ext cx="4724400" cy="523220"/>
+          </a:xfrm>
+          <a:prstGeom prst="rect">
+            <a:avLst/>
+          </a:prstGeom>
+          <a:noFill/>
+        </p:spPr>
+        <p:txBody>
+          <a:bodyPr wrap="square" rtlCol="0">
+            <a:spAutoFit/>
+          </a:bodyPr>
+          <a:lstStyle/>
+          <a:p>
+            <a:r>
+              <a:rPr lang="en-US" sz="2800" dirty="0">
+                <a:solidFill>
+                  <a:srgbClr val="FFC000"/>
+                </a:solidFill>
+                <a:latin typeface="Segoe UI" panose="020B0502040204020203" pitchFamily="34" charset="0"/>
+                <a:cs typeface="Segoe UI" panose="020B0502040204020203" pitchFamily="34" charset="0"/>
+              </a:rPr>
+              <a:t>Row comparison</a:t>
+            </a:r>
+          </a:p>
+        </p:txBody>
+      </p:sp>
+      <p:sp>
+        <p:nvSpPr>
+          <p:cNvPr id="12" name="TextBox 11">
+            <a:extLst>
+              <a:ext uri="{FF2B5EF4-FFF2-40B4-BE49-F238E27FC236}">
+                <a16:creationId xmlns:a16="http://schemas.microsoft.com/office/drawing/2014/main" id="{59A70E8B-C511-4588-94E7-53A78F849AF3}"/>
+              </a:ext>
+            </a:extLst>
+          </p:cNvPr>
+          <p:cNvSpPr txBox="1"/>
+          <p:nvPr/>
+        </p:nvSpPr>
+        <p:spPr>
+          <a:xfrm>
+            <a:off x="2050518" y="6305235"/>
+            <a:ext cx="4724400" cy="523220"/>
+          </a:xfrm>
+          <a:prstGeom prst="rect">
+            <a:avLst/>
+          </a:prstGeom>
+          <a:noFill/>
+        </p:spPr>
+        <p:txBody>
+          <a:bodyPr wrap="square" rtlCol="0">
+            <a:spAutoFit/>
+          </a:bodyPr>
+          <a:lstStyle/>
+          <a:p>
+            <a:r>
+              <a:rPr lang="en-US" sz="2800" dirty="0">
+                <a:solidFill>
+                  <a:srgbClr val="FFC000"/>
+                </a:solidFill>
+                <a:latin typeface="Segoe UI" panose="020B0502040204020203" pitchFamily="34" charset="0"/>
+                <a:cs typeface="Segoe UI" panose="020B0502040204020203" pitchFamily="34" charset="0"/>
+              </a:rPr>
+              <a:t>Entra ID identity lookups</a:t>
+            </a:r>
+          </a:p>
+        </p:txBody>
+      </p:sp>
+      <p:sp>
+        <p:nvSpPr>
+          <p:cNvPr id="13" name="TextBox 12">
+            <a:extLst>
+              <a:ext uri="{FF2B5EF4-FFF2-40B4-BE49-F238E27FC236}">
+                <a16:creationId xmlns:a16="http://schemas.microsoft.com/office/drawing/2014/main" id="{E4BBF9FB-6839-BEAA-2E4C-144A093CB2CB}"/>
+              </a:ext>
+            </a:extLst>
+          </p:cNvPr>
+          <p:cNvSpPr txBox="1"/>
+          <p:nvPr/>
+        </p:nvSpPr>
+        <p:spPr>
+          <a:xfrm>
+            <a:off x="12628620" y="4743592"/>
+            <a:ext cx="4724400" cy="523220"/>
+          </a:xfrm>
+          <a:prstGeom prst="rect">
+            <a:avLst/>
+          </a:prstGeom>
+          <a:noFill/>
+        </p:spPr>
+        <p:txBody>
+          <a:bodyPr wrap="square" rtlCol="0">
+            <a:spAutoFit/>
+          </a:bodyPr>
+          <a:lstStyle/>
+          <a:p>
+            <a:r>
+              <a:rPr lang="en-US" sz="2800" dirty="0">
+                <a:solidFill>
+                  <a:srgbClr val="FFC000"/>
+                </a:solidFill>
+                <a:latin typeface="Segoe UI" panose="020B0502040204020203" pitchFamily="34" charset="0"/>
+                <a:cs typeface="Segoe UI" panose="020B0502040204020203" pitchFamily="34" charset="0"/>
+              </a:rPr>
+              <a:t>Built-in documentation</a:t>
+            </a:r>
+          </a:p>
+        </p:txBody>
+      </p:sp>
+      <p:sp>
+        <p:nvSpPr>
+          <p:cNvPr id="18" name="Title 1">
+            <a:extLst>
+              <a:ext uri="{FF2B5EF4-FFF2-40B4-BE49-F238E27FC236}">
+                <a16:creationId xmlns:a16="http://schemas.microsoft.com/office/drawing/2014/main" id="{BAF4F5A1-5F36-1841-407B-1EFC90A4F7E1}"/>
+              </a:ext>
+            </a:extLst>
+          </p:cNvPr>
+          <p:cNvSpPr>
+            <a:spLocks noGrp="1"/>
+          </p:cNvSpPr>
+          <p:nvPr>
+            <p:ph type="title"/>
+          </p:nvPr>
+        </p:nvSpPr>
+        <p:spPr>
+          <a:xfrm>
+            <a:off x="3467100" y="664125"/>
+            <a:ext cx="15773400" cy="1351120"/>
+          </a:xfrm>
+        </p:spPr>
+        <p:txBody>
+          <a:bodyPr/>
+          <a:lstStyle/>
+          <a:p>
+            <a:r>
+              <a:rPr dirty="0">
+                <a:solidFill>
+                  <a:srgbClr val="F7F9FF"/>
+                </a:solidFill>
+                <a:latin typeface="Segoe UI Semibold"/>
+              </a:rPr>
+              <a:t>Azure Resource Graph Explorer</a:t>
+            </a:r>
+          </a:p>
+        </p:txBody>
+      </p:sp>
+      <p:sp>
+        <p:nvSpPr>
+          <p:cNvPr id="19" name="Title 1">
+            <a:extLst>
+              <a:ext uri="{FF2B5EF4-FFF2-40B4-BE49-F238E27FC236}">
+                <a16:creationId xmlns:a16="http://schemas.microsoft.com/office/drawing/2014/main" id="{710CC631-78F2-D9D3-29DC-960AD1355261}"/>
+              </a:ext>
+            </a:extLst>
+          </p:cNvPr>
+          <p:cNvSpPr txBox="1">
+            <a:spLocks/>
+          </p:cNvSpPr>
+          <p:nvPr/>
+        </p:nvSpPr>
+        <p:spPr>
+          <a:xfrm>
+            <a:off x="162030" y="688695"/>
+            <a:ext cx="15773400" cy="1351120"/>
+          </a:xfrm>
+          <a:prstGeom prst="rect">
+            <a:avLst/>
+          </a:prstGeom>
+        </p:spPr>
+        <p:txBody>
+          <a:bodyPr vert="horz" lIns="91440" tIns="45720" rIns="91440" bIns="45720" rtlCol="0" anchor="ctr">
+            <a:normAutofit/>
+          </a:bodyPr>
+          <a:lstStyle>
+            <a:lvl1pPr algn="l" defTabSz="914400" rtl="0" eaLnBrk="1" latinLnBrk="0" hangingPunct="1">
+              <a:spcBef>
+                <a:spcPct val="0"/>
+              </a:spcBef>
+              <a:buNone/>
+              <a:defRPr sz="6000" b="1" kern="1200">
+                <a:solidFill>
+                  <a:schemeClr val="accent5"/>
+                </a:solidFill>
+                <a:latin typeface="+mj-lt"/>
+                <a:ea typeface="+mj-ea"/>
+                <a:cs typeface="+mj-cs"/>
+              </a:defRPr>
+            </a:lvl1pPr>
+          </a:lstStyle>
+          <a:p>
+            <a:r>
+              <a:rPr lang="en-US" dirty="0">
+                <a:solidFill>
+                  <a:srgbClr val="FFC000"/>
+                </a:solidFill>
+                <a:latin typeface="Cascadia Code" panose="020B0609020000020004" pitchFamily="34" charset="0"/>
+                <a:ea typeface="Cascadia Code" panose="020B0609020000020004" pitchFamily="34" charset="0"/>
+                <a:cs typeface="Cascadia Code" panose="020B0609020000020004" pitchFamily="34" charset="0"/>
+              </a:rPr>
+              <a:t>boosted</a:t>
+            </a:r>
+          </a:p>
+        </p:txBody>
+      </p:sp>
     </p:spTree>
   </p:cSld>
   <p:clrMapOvr>
@@ -8731,6 +9151,470 @@
       </p:transition>
     </mc:Fallback>
   </mc:AlternateContent>
+  <p:timing>
+    <p:tnLst>
+      <p:par>
+        <p:cTn id="1" dur="indefinite" restart="never" nodeType="tmRoot">
+          <p:childTnLst>
+            <p:seq concurrent="1" nextAc="seek">
+              <p:cTn id="2" dur="indefinite" nodeType="mainSeq">
+                <p:childTnLst>
+                  <p:par>
+                    <p:cTn id="3" fill="hold">
+                      <p:stCondLst>
+                        <p:cond delay="indefinite"/>
+                      </p:stCondLst>
+                      <p:childTnLst>
+                        <p:par>
+                          <p:cTn id="4" fill="hold">
+                            <p:stCondLst>
+                              <p:cond delay="0"/>
+                            </p:stCondLst>
+                            <p:childTnLst>
+                              <p:par>
+                                <p:cTn id="5" presetID="10" presetClass="entr" presetSubtype="0" fill="hold" grpId="0" nodeType="clickEffect">
+                                  <p:stCondLst>
+                                    <p:cond delay="0"/>
+                                  </p:stCondLst>
+                                  <p:childTnLst>
+                                    <p:set>
+                                      <p:cBhvr>
+                                        <p:cTn id="6" dur="1" fill="hold">
+                                          <p:stCondLst>
+                                            <p:cond delay="0"/>
+                                          </p:stCondLst>
+                                        </p:cTn>
+                                        <p:tgtEl>
+                                          <p:spTgt spid="3"/>
+                                        </p:tgtEl>
+                                        <p:attrNameLst>
+                                          <p:attrName>style.visibility</p:attrName>
+                                        </p:attrNameLst>
+                                      </p:cBhvr>
+                                      <p:to>
+                                        <p:strVal val="visible"/>
+                                      </p:to>
+                                    </p:set>
+                                    <p:animEffect transition="in" filter="fade">
+                                      <p:cBhvr>
+                                        <p:cTn id="7" dur="500"/>
+                                        <p:tgtEl>
+                                          <p:spTgt spid="3"/>
+                                        </p:tgtEl>
+                                      </p:cBhvr>
+                                    </p:animEffect>
+                                  </p:childTnLst>
+                                </p:cTn>
+                              </p:par>
+                            </p:childTnLst>
+                          </p:cTn>
+                        </p:par>
+                      </p:childTnLst>
+                    </p:cTn>
+                  </p:par>
+                  <p:par>
+                    <p:cTn id="8" fill="hold">
+                      <p:stCondLst>
+                        <p:cond delay="indefinite"/>
+                      </p:stCondLst>
+                      <p:childTnLst>
+                        <p:par>
+                          <p:cTn id="9" fill="hold">
+                            <p:stCondLst>
+                              <p:cond delay="0"/>
+                            </p:stCondLst>
+                            <p:childTnLst>
+                              <p:par>
+                                <p:cTn id="10" presetID="10" presetClass="entr" presetSubtype="0" fill="hold" grpId="0" nodeType="clickEffect">
+                                  <p:stCondLst>
+                                    <p:cond delay="0"/>
+                                  </p:stCondLst>
+                                  <p:childTnLst>
+                                    <p:set>
+                                      <p:cBhvr>
+                                        <p:cTn id="11" dur="1" fill="hold">
+                                          <p:stCondLst>
+                                            <p:cond delay="0"/>
+                                          </p:stCondLst>
+                                        </p:cTn>
+                                        <p:tgtEl>
+                                          <p:spTgt spid="4"/>
+                                        </p:tgtEl>
+                                        <p:attrNameLst>
+                                          <p:attrName>style.visibility</p:attrName>
+                                        </p:attrNameLst>
+                                      </p:cBhvr>
+                                      <p:to>
+                                        <p:strVal val="visible"/>
+                                      </p:to>
+                                    </p:set>
+                                    <p:animEffect transition="in" filter="fade">
+                                      <p:cBhvr>
+                                        <p:cTn id="12" dur="500"/>
+                                        <p:tgtEl>
+                                          <p:spTgt spid="4"/>
+                                        </p:tgtEl>
+                                      </p:cBhvr>
+                                    </p:animEffect>
+                                  </p:childTnLst>
+                                </p:cTn>
+                              </p:par>
+                            </p:childTnLst>
+                          </p:cTn>
+                        </p:par>
+                      </p:childTnLst>
+                    </p:cTn>
+                  </p:par>
+                  <p:par>
+                    <p:cTn id="13" fill="hold">
+                      <p:stCondLst>
+                        <p:cond delay="indefinite"/>
+                      </p:stCondLst>
+                      <p:childTnLst>
+                        <p:par>
+                          <p:cTn id="14" fill="hold">
+                            <p:stCondLst>
+                              <p:cond delay="0"/>
+                            </p:stCondLst>
+                            <p:childTnLst>
+                              <p:par>
+                                <p:cTn id="15" presetID="10" presetClass="entr" presetSubtype="0" fill="hold" grpId="0" nodeType="clickEffect">
+                                  <p:stCondLst>
+                                    <p:cond delay="0"/>
+                                  </p:stCondLst>
+                                  <p:childTnLst>
+                                    <p:set>
+                                      <p:cBhvr>
+                                        <p:cTn id="16" dur="1" fill="hold">
+                                          <p:stCondLst>
+                                            <p:cond delay="0"/>
+                                          </p:stCondLst>
+                                        </p:cTn>
+                                        <p:tgtEl>
+                                          <p:spTgt spid="5"/>
+                                        </p:tgtEl>
+                                        <p:attrNameLst>
+                                          <p:attrName>style.visibility</p:attrName>
+                                        </p:attrNameLst>
+                                      </p:cBhvr>
+                                      <p:to>
+                                        <p:strVal val="visible"/>
+                                      </p:to>
+                                    </p:set>
+                                    <p:animEffect transition="in" filter="fade">
+                                      <p:cBhvr>
+                                        <p:cTn id="17" dur="500"/>
+                                        <p:tgtEl>
+                                          <p:spTgt spid="5"/>
+                                        </p:tgtEl>
+                                      </p:cBhvr>
+                                    </p:animEffect>
+                                  </p:childTnLst>
+                                </p:cTn>
+                              </p:par>
+                            </p:childTnLst>
+                          </p:cTn>
+                        </p:par>
+                      </p:childTnLst>
+                    </p:cTn>
+                  </p:par>
+                  <p:par>
+                    <p:cTn id="18" fill="hold">
+                      <p:stCondLst>
+                        <p:cond delay="indefinite"/>
+                      </p:stCondLst>
+                      <p:childTnLst>
+                        <p:par>
+                          <p:cTn id="19" fill="hold">
+                            <p:stCondLst>
+                              <p:cond delay="0"/>
+                            </p:stCondLst>
+                            <p:childTnLst>
+                              <p:par>
+                                <p:cTn id="20" presetID="10" presetClass="entr" presetSubtype="0" fill="hold" grpId="0" nodeType="clickEffect">
+                                  <p:stCondLst>
+                                    <p:cond delay="0"/>
+                                  </p:stCondLst>
+                                  <p:childTnLst>
+                                    <p:set>
+                                      <p:cBhvr>
+                                        <p:cTn id="21" dur="1" fill="hold">
+                                          <p:stCondLst>
+                                            <p:cond delay="0"/>
+                                          </p:stCondLst>
+                                        </p:cTn>
+                                        <p:tgtEl>
+                                          <p:spTgt spid="7"/>
+                                        </p:tgtEl>
+                                        <p:attrNameLst>
+                                          <p:attrName>style.visibility</p:attrName>
+                                        </p:attrNameLst>
+                                      </p:cBhvr>
+                                      <p:to>
+                                        <p:strVal val="visible"/>
+                                      </p:to>
+                                    </p:set>
+                                    <p:animEffect transition="in" filter="fade">
+                                      <p:cBhvr>
+                                        <p:cTn id="22" dur="500"/>
+                                        <p:tgtEl>
+                                          <p:spTgt spid="7"/>
+                                        </p:tgtEl>
+                                      </p:cBhvr>
+                                    </p:animEffect>
+                                  </p:childTnLst>
+                                </p:cTn>
+                              </p:par>
+                            </p:childTnLst>
+                          </p:cTn>
+                        </p:par>
+                      </p:childTnLst>
+                    </p:cTn>
+                  </p:par>
+                  <p:par>
+                    <p:cTn id="23" fill="hold">
+                      <p:stCondLst>
+                        <p:cond delay="indefinite"/>
+                      </p:stCondLst>
+                      <p:childTnLst>
+                        <p:par>
+                          <p:cTn id="24" fill="hold">
+                            <p:stCondLst>
+                              <p:cond delay="0"/>
+                            </p:stCondLst>
+                            <p:childTnLst>
+                              <p:par>
+                                <p:cTn id="25" presetID="10" presetClass="entr" presetSubtype="0" fill="hold" grpId="0" nodeType="clickEffect">
+                                  <p:stCondLst>
+                                    <p:cond delay="0"/>
+                                  </p:stCondLst>
+                                  <p:childTnLst>
+                                    <p:set>
+                                      <p:cBhvr>
+                                        <p:cTn id="26" dur="1" fill="hold">
+                                          <p:stCondLst>
+                                            <p:cond delay="0"/>
+                                          </p:stCondLst>
+                                        </p:cTn>
+                                        <p:tgtEl>
+                                          <p:spTgt spid="8"/>
+                                        </p:tgtEl>
+                                        <p:attrNameLst>
+                                          <p:attrName>style.visibility</p:attrName>
+                                        </p:attrNameLst>
+                                      </p:cBhvr>
+                                      <p:to>
+                                        <p:strVal val="visible"/>
+                                      </p:to>
+                                    </p:set>
+                                    <p:animEffect transition="in" filter="fade">
+                                      <p:cBhvr>
+                                        <p:cTn id="27" dur="500"/>
+                                        <p:tgtEl>
+                                          <p:spTgt spid="8"/>
+                                        </p:tgtEl>
+                                      </p:cBhvr>
+                                    </p:animEffect>
+                                  </p:childTnLst>
+                                </p:cTn>
+                              </p:par>
+                            </p:childTnLst>
+                          </p:cTn>
+                        </p:par>
+                      </p:childTnLst>
+                    </p:cTn>
+                  </p:par>
+                  <p:par>
+                    <p:cTn id="28" fill="hold">
+                      <p:stCondLst>
+                        <p:cond delay="indefinite"/>
+                      </p:stCondLst>
+                      <p:childTnLst>
+                        <p:par>
+                          <p:cTn id="29" fill="hold">
+                            <p:stCondLst>
+                              <p:cond delay="0"/>
+                            </p:stCondLst>
+                            <p:childTnLst>
+                              <p:par>
+                                <p:cTn id="30" presetID="10" presetClass="entr" presetSubtype="0" fill="hold" grpId="0" nodeType="clickEffect">
+                                  <p:stCondLst>
+                                    <p:cond delay="0"/>
+                                  </p:stCondLst>
+                                  <p:childTnLst>
+                                    <p:set>
+                                      <p:cBhvr>
+                                        <p:cTn id="31" dur="1" fill="hold">
+                                          <p:stCondLst>
+                                            <p:cond delay="0"/>
+                                          </p:stCondLst>
+                                        </p:cTn>
+                                        <p:tgtEl>
+                                          <p:spTgt spid="9"/>
+                                        </p:tgtEl>
+                                        <p:attrNameLst>
+                                          <p:attrName>style.visibility</p:attrName>
+                                        </p:attrNameLst>
+                                      </p:cBhvr>
+                                      <p:to>
+                                        <p:strVal val="visible"/>
+                                      </p:to>
+                                    </p:set>
+                                    <p:animEffect transition="in" filter="fade">
+                                      <p:cBhvr>
+                                        <p:cTn id="32" dur="500"/>
+                                        <p:tgtEl>
+                                          <p:spTgt spid="9"/>
+                                        </p:tgtEl>
+                                      </p:cBhvr>
+                                    </p:animEffect>
+                                  </p:childTnLst>
+                                </p:cTn>
+                              </p:par>
+                            </p:childTnLst>
+                          </p:cTn>
+                        </p:par>
+                      </p:childTnLst>
+                    </p:cTn>
+                  </p:par>
+                  <p:par>
+                    <p:cTn id="33" fill="hold">
+                      <p:stCondLst>
+                        <p:cond delay="indefinite"/>
+                      </p:stCondLst>
+                      <p:childTnLst>
+                        <p:par>
+                          <p:cTn id="34" fill="hold">
+                            <p:stCondLst>
+                              <p:cond delay="0"/>
+                            </p:stCondLst>
+                            <p:childTnLst>
+                              <p:par>
+                                <p:cTn id="35" presetID="10" presetClass="entr" presetSubtype="0" fill="hold" grpId="0" nodeType="clickEffect">
+                                  <p:stCondLst>
+                                    <p:cond delay="0"/>
+                                  </p:stCondLst>
+                                  <p:childTnLst>
+                                    <p:set>
+                                      <p:cBhvr>
+                                        <p:cTn id="36" dur="1" fill="hold">
+                                          <p:stCondLst>
+                                            <p:cond delay="0"/>
+                                          </p:stCondLst>
+                                        </p:cTn>
+                                        <p:tgtEl>
+                                          <p:spTgt spid="12"/>
+                                        </p:tgtEl>
+                                        <p:attrNameLst>
+                                          <p:attrName>style.visibility</p:attrName>
+                                        </p:attrNameLst>
+                                      </p:cBhvr>
+                                      <p:to>
+                                        <p:strVal val="visible"/>
+                                      </p:to>
+                                    </p:set>
+                                    <p:animEffect transition="in" filter="fade">
+                                      <p:cBhvr>
+                                        <p:cTn id="37" dur="500"/>
+                                        <p:tgtEl>
+                                          <p:spTgt spid="12"/>
+                                        </p:tgtEl>
+                                      </p:cBhvr>
+                                    </p:animEffect>
+                                  </p:childTnLst>
+                                </p:cTn>
+                              </p:par>
+                            </p:childTnLst>
+                          </p:cTn>
+                        </p:par>
+                      </p:childTnLst>
+                    </p:cTn>
+                  </p:par>
+                  <p:par>
+                    <p:cTn id="38" fill="hold">
+                      <p:stCondLst>
+                        <p:cond delay="indefinite"/>
+                      </p:stCondLst>
+                      <p:childTnLst>
+                        <p:par>
+                          <p:cTn id="39" fill="hold">
+                            <p:stCondLst>
+                              <p:cond delay="0"/>
+                            </p:stCondLst>
+                            <p:childTnLst>
+                              <p:par>
+                                <p:cTn id="40" presetID="10" presetClass="entr" presetSubtype="0" fill="hold" grpId="0" nodeType="clickEffect">
+                                  <p:stCondLst>
+                                    <p:cond delay="0"/>
+                                  </p:stCondLst>
+                                  <p:childTnLst>
+                                    <p:set>
+                                      <p:cBhvr>
+                                        <p:cTn id="41" dur="1" fill="hold">
+                                          <p:stCondLst>
+                                            <p:cond delay="0"/>
+                                          </p:stCondLst>
+                                        </p:cTn>
+                                        <p:tgtEl>
+                                          <p:spTgt spid="13"/>
+                                        </p:tgtEl>
+                                        <p:attrNameLst>
+                                          <p:attrName>style.visibility</p:attrName>
+                                        </p:attrNameLst>
+                                      </p:cBhvr>
+                                      <p:to>
+                                        <p:strVal val="visible"/>
+                                      </p:to>
+                                    </p:set>
+                                    <p:animEffect transition="in" filter="fade">
+                                      <p:cBhvr>
+                                        <p:cTn id="42" dur="500"/>
+                                        <p:tgtEl>
+                                          <p:spTgt spid="13"/>
+                                        </p:tgtEl>
+                                      </p:cBhvr>
+                                    </p:animEffect>
+                                  </p:childTnLst>
+                                </p:cTn>
+                              </p:par>
+                            </p:childTnLst>
+                          </p:cTn>
+                        </p:par>
+                      </p:childTnLst>
+                    </p:cTn>
+                  </p:par>
+                </p:childTnLst>
+              </p:cTn>
+              <p:prevCondLst>
+                <p:cond evt="onPrev" delay="0">
+                  <p:tgtEl>
+                    <p:sldTgt/>
+                  </p:tgtEl>
+                </p:cond>
+              </p:prevCondLst>
+              <p:nextCondLst>
+                <p:cond evt="onNext" delay="0">
+                  <p:tgtEl>
+                    <p:sldTgt/>
+                  </p:tgtEl>
+                </p:cond>
+              </p:nextCondLst>
+            </p:seq>
+          </p:childTnLst>
+        </p:cTn>
+      </p:par>
+    </p:tnLst>
+    <p:bldLst>
+      <p:bldP spid="3" grpId="0"/>
+      <p:bldP spid="4" grpId="0"/>
+      <p:bldP spid="5" grpId="0"/>
+      <p:bldP spid="7" grpId="0"/>
+      <p:bldP spid="8" grpId="0"/>
+      <p:bldP spid="9" grpId="0"/>
+      <p:bldP spid="12" grpId="0"/>
+      <p:bldP spid="13" grpId="0"/>
+    </p:bldLst>
+  </p:timing>
 </p:sld>
 </file>
 
@@ -24749,7 +25633,7 @@
                 <a:latin typeface="Segoe UI" panose="020B0502040204020203" pitchFamily="34" charset="0"/>
                 <a:cs typeface="Segoe UI" panose="020B0502040204020203" pitchFamily="34" charset="0"/>
               </a:rPr>
-              <a:t>), CLI, dashboards, alerts and more</a:t>
+              <a:t>), CLIs, dashboards, alerts and more</a:t>
             </a:r>
           </a:p>
         </p:txBody>
@@ -26551,8 +27435,8 @@
         </p:nvSpPr>
         <p:spPr>
           <a:xfrm>
-            <a:off x="11118441" y="4501532"/>
-            <a:ext cx="6858000" cy="877162"/>
+            <a:off x="12232699" y="3977236"/>
+            <a:ext cx="6858000" cy="1446550"/>
           </a:xfrm>
           <a:prstGeom prst="rect">
             <a:avLst/>
@@ -26566,7 +27450,7 @@
           <a:lstStyle/>
           <a:p>
             <a:r>
-              <a:rPr lang="en-US" sz="4800" b="1" dirty="0">
+              <a:rPr lang="en-US" sz="4400" b="1" dirty="0">
                 <a:solidFill>
                   <a:schemeClr val="tx1"/>
                 </a:solidFill>
@@ -26576,24 +27460,44 @@
               <a:t>Install </a:t>
             </a:r>
             <a:r>
-              <a:rPr lang="en-US" sz="4800" b="1" dirty="0" err="1">
-                <a:solidFill>
-                  <a:schemeClr val="tx1"/>
-                </a:solidFill>
+              <a:rPr lang="en-US" sz="4400" dirty="0" err="1">
+                <a:solidFill>
+                  <a:srgbClr val="FFC000"/>
+                </a:solidFill>
+                <a:latin typeface="Cascadia Code" panose="020B0609020000020004" pitchFamily="34" charset="0"/>
                 <a:ea typeface="Cascadia Code" panose="020B0609020000020004" pitchFamily="34" charset="0"/>
                 <a:cs typeface="Cascadia Code" panose="020B0609020000020004" pitchFamily="34" charset="0"/>
               </a:rPr>
               <a:t>bARGE</a:t>
             </a:r>
             <a:r>
-              <a:rPr lang="en-US" sz="4800" b="1" dirty="0">
+              <a:rPr lang="en-US" sz="4400" b="1" dirty="0">
                 <a:solidFill>
                   <a:schemeClr val="tx1"/>
                 </a:solidFill>
                 <a:ea typeface="Cascadia Code" panose="020B0609020000020004" pitchFamily="34" charset="0"/>
                 <a:cs typeface="Cascadia Code" panose="020B0609020000020004" pitchFamily="34" charset="0"/>
               </a:rPr>
-              <a:t> here!</a:t>
+              <a:t> here</a:t>
+            </a:r>
+            <a:br>
+              <a:rPr lang="en-US" sz="4400" b="1" dirty="0">
+                <a:solidFill>
+                  <a:schemeClr val="tx1"/>
+                </a:solidFill>
+                <a:ea typeface="Cascadia Code" panose="020B0609020000020004" pitchFamily="34" charset="0"/>
+                <a:cs typeface="Cascadia Code" panose="020B0609020000020004" pitchFamily="34" charset="0"/>
+              </a:rPr>
+            </a:br>
+            <a:r>
+              <a:rPr lang="en-US" sz="4400" b="1" dirty="0">
+                <a:solidFill>
+                  <a:schemeClr val="tx1"/>
+                </a:solidFill>
+                <a:ea typeface="Cascadia Code" panose="020B0609020000020004" pitchFamily="34" charset="0"/>
+                <a:cs typeface="Cascadia Code" panose="020B0609020000020004" pitchFamily="34" charset="0"/>
+              </a:rPr>
+              <a:t>if you’re curious</a:t>
             </a:r>
           </a:p>
         </p:txBody>

</xml_diff>